<commit_message>
Switch pricing from rubles to tenge (3 990 ₸ Pro / 2 990 ₸ Team)
</commit_message>
<xml_diff>
--- a/WhisperFly-Pitch-RU.pptx
+++ b/WhisperFly-Pitch-RU.pptx
@@ -3859,7 +3859,7 @@
                 </a:solidFill>
                 <a:latin typeface="Rubik"/>
               </a:rPr>
-              <a:t>Диктовка нажатием клавиши для macOS. Голос — в текст: мгновенно, в любом приложении и без единого рубля за подписку.</a:t>
+              <a:t>Диктовка нажатием клавиши для macOS. Голос — в текст: мгновенно, в любом приложении и без единого тенге за подписку.</a:t>
             </a:r>
           </a:p>
         </p:txBody>
@@ -4144,7 +4144,7 @@
                 </a:solidFill>
                 <a:latin typeface="JetBrains Mono"/>
               </a:rPr>
-              <a:t>0 ₽</a:t>
+              <a:t>0 ₸</a:t>
             </a:r>
           </a:p>
         </p:txBody>
@@ -20955,7 +20955,7 @@
                 </a:solidFill>
                 <a:latin typeface="JetBrains Mono"/>
               </a:rPr>
-              <a:t>0 ₽ — порог входа</a:t>
+              <a:t>0 ₸ — порог входа</a:t>
             </a:r>
           </a:p>
         </p:txBody>
@@ -21829,7 +21829,7 @@
                 </a:solidFill>
                 <a:latin typeface="Unbounded"/>
               </a:rPr>
-              <a:t>FREE · 0 ₽</a:t>
+              <a:t>FREE · 0 ₸</a:t>
             </a:r>
           </a:p>
         </p:txBody>
@@ -21961,7 +21961,7 @@
                 </a:solidFill>
                 <a:latin typeface="Unbounded"/>
               </a:rPr>
-              <a:t>PRO · 690 ₽/МЕС</a:t>
+              <a:t>PRO · 3 990 ₸/МЕС</a:t>
             </a:r>
           </a:p>
         </p:txBody>
@@ -22093,7 +22093,7 @@
                 </a:solidFill>
                 <a:latin typeface="Unbounded"/>
               </a:rPr>
-              <a:t>TEAM · ОТ 490 ₽</a:t>
+              <a:t>TEAM · ОТ 2 990 ₸</a:t>
             </a:r>
           </a:p>
         </p:txBody>
@@ -23518,7 +23518,7 @@
                 </a:solidFill>
                 <a:latin typeface="Rubik"/>
               </a:rPr>
-              <a:t>0 ₽</a:t>
+              <a:t>0 ₸</a:t>
             </a:r>
           </a:p>
         </p:txBody>
@@ -24578,7 +24578,7 @@
                 </a:solidFill>
                 <a:latin typeface="Rubik"/>
               </a:rPr>
-              <a:t>0 ₽</a:t>
+              <a:t>0 ₸</a:t>
             </a:r>
           </a:p>
         </p:txBody>

</xml_diff>

<commit_message>
Add Kazakh to UI language list: 10 -> 11 interface languages
</commit_message>
<xml_diff>
--- a/WhisperFly-Pitch-RU.pptx
+++ b/WhisperFly-Pitch-RU.pptx
@@ -4030,7 +4030,7 @@
                 </a:solidFill>
                 <a:latin typeface="JetBrains Mono"/>
               </a:rPr>
-              <a:t>10 ЯЗЫКОВ</a:t>
+              <a:t>11 ЯЗЫКОВ</a:t>
             </a:r>
           </a:p>
         </p:txBody>
@@ -5240,7 +5240,7 @@
                 </a:solidFill>
                 <a:latin typeface="Unbounded"/>
               </a:rPr>
-              <a:t>10</a:t>
+              <a:t>11</a:t>
             </a:r>
           </a:p>
         </p:txBody>
@@ -11117,7 +11117,7 @@
                 </a:solidFill>
                 <a:latin typeface="JetBrains Mono"/>
               </a:rPr>
-              <a:t>ОТКРЫТЫЙ ИСХОДНЫЙ КОД · MACOS 14+ · 10 ЯЗЫКОВ</a:t>
+              <a:t>ОТКРЫТЫЙ ИСХОДНЫЙ КОД · MACOS 14+ · 11 ЯЗЫКОВ</a:t>
             </a:r>
           </a:p>
         </p:txBody>
@@ -17185,7 +17185,7 @@
                 </a:solidFill>
                 <a:latin typeface="Unbounded"/>
               </a:rPr>
-              <a:t>10 ЯЗЫКОВ ИНТЕРФЕЙСА</a:t>
+              <a:t>11 ЯЗЫКОВ ИНТЕРФЕЙСА</a:t>
             </a:r>
           </a:p>
         </p:txBody>
@@ -17227,7 +17227,7 @@
                 </a:solidFill>
                 <a:latin typeface="Rubik"/>
               </a:rPr>
-              <a:t>Русский, английский, немецкий, французский, испанский, японский, китайский, корейский, итальянский, хинди.</a:t>
+              <a:t>Русский, английский, казахский, немецкий, французский, испанский, японский, китайский, корейский, итальянский, хинди.</a:t>
             </a:r>
           </a:p>
         </p:txBody>
@@ -21871,7 +21871,7 @@
                 </a:solidFill>
                 <a:latin typeface="Rubik"/>
               </a:rPr>
-              <a:t>Всё ядро без ограничений: два движка, транскрипция файлов, история, 10 языков. Исходный код открыт.</a:t>
+              <a:t>Всё ядро без ограничений: два движка, транскрипция файлов, история, 11 языков. Исходный код открыт.</a:t>
             </a:r>
           </a:p>
         </p:txBody>

</xml_diff>

<commit_message>
Retarget the deck at PIZZA PITCH (SKO Hub): real app icon on the title slide, rewritten funding slide for the 150k tenge prize and the 10k USD GitHub grant, rebased timeline to Q4 2026-Q4 2027 and results to 5 000 installs, rebuilt PDF and PPTX
</commit_message>
<xml_diff>
--- a/WhisperFly-Pitch-RU.pptx
+++ b/WhisperFly-Pitch-RU.pptx
@@ -3769,331 +3769,33 @@
           </a:p>
         </p:txBody>
       </p:sp>
-      <p:sp>
-        <p:nvSpPr>
-          <p:cNvPr id="17" name="Rounded Rectangle 16"/>
-          <p:cNvSpPr/>
-          <p:nvPr/>
-        </p:nvSpPr>
-        <p:spPr>
-          <a:xfrm>
-            <a:off x="5230368" y="475488"/>
-            <a:ext cx="1572768" cy="1572768"/>
-          </a:xfrm>
-          <a:prstGeom prst="roundRect">
-            <a:avLst>
-              <a:gd name="adj" fmla="val 22000"/>
-            </a:avLst>
-          </a:prstGeom>
-          <a:solidFill>
-            <a:srgbClr val="1C2447"/>
-          </a:solidFill>
-          <a:ln w="28575">
-            <a:solidFill>
-              <a:srgbClr val="1C2447"/>
-            </a:solidFill>
-          </a:ln>
-          <a:effectLst/>
-        </p:spPr>
-        <p:style>
-          <a:lnRef idx="1">
-            <a:schemeClr val="accent1"/>
-          </a:lnRef>
-          <a:fillRef idx="3">
-            <a:schemeClr val="accent1"/>
-          </a:fillRef>
-          <a:effectRef idx="2">
-            <a:schemeClr val="accent1"/>
-          </a:effectRef>
-          <a:fontRef idx="minor">
-            <a:schemeClr val="lt1"/>
-          </a:fontRef>
-        </p:style>
-        <p:txBody>
-          <a:bodyPr rtlCol="0" anchor="ctr"/>
-          <a:lstStyle/>
-          <a:p>
-            <a:pPr algn="ctr"/>
-          </a:p>
-        </p:txBody>
-      </p:sp>
-      <p:sp>
-        <p:nvSpPr>
-          <p:cNvPr id="18" name="Oval 17"/>
-          <p:cNvSpPr/>
-          <p:nvPr/>
-        </p:nvSpPr>
-        <p:spPr>
-          <a:xfrm>
-            <a:off x="5413248" y="658368"/>
-            <a:ext cx="1207008" cy="1207008"/>
-          </a:xfrm>
-          <a:prstGeom prst="ellipse">
-            <a:avLst/>
-          </a:prstGeom>
-          <a:noFill/>
-          <a:ln w="25400">
-            <a:solidFill>
-              <a:srgbClr val="FA9E56"/>
-            </a:solidFill>
-          </a:ln>
-          <a:effectLst/>
-        </p:spPr>
-        <p:style>
-          <a:lnRef idx="1">
-            <a:schemeClr val="accent1"/>
-          </a:lnRef>
-          <a:fillRef idx="3">
-            <a:schemeClr val="accent1"/>
-          </a:fillRef>
-          <a:effectRef idx="2">
-            <a:schemeClr val="accent1"/>
-          </a:effectRef>
-          <a:fontRef idx="minor">
-            <a:schemeClr val="lt1"/>
-          </a:fontRef>
-        </p:style>
-        <p:txBody>
-          <a:bodyPr rtlCol="0" anchor="ctr"/>
-          <a:lstStyle/>
-          <a:p>
-            <a:pPr algn="ctr"/>
-          </a:p>
-        </p:txBody>
-      </p:sp>
-      <p:sp>
-        <p:nvSpPr>
-          <p:cNvPr id="19" name="Rounded Rectangle 18"/>
-          <p:cNvSpPr/>
-          <p:nvPr/>
-        </p:nvSpPr>
-        <p:spPr>
-          <a:xfrm>
-            <a:off x="5613046" y="1124712"/>
-            <a:ext cx="123444" cy="274320"/>
-          </a:xfrm>
-          <a:prstGeom prst="roundRect">
-            <a:avLst>
-              <a:gd name="adj" fmla="val 50000"/>
-            </a:avLst>
-          </a:prstGeom>
-          <a:solidFill>
-            <a:srgbClr val="FDFCF8"/>
-          </a:solidFill>
-          <a:ln>
-            <a:noFill/>
-          </a:ln>
-          <a:effectLst/>
-        </p:spPr>
-        <p:style>
-          <a:lnRef idx="1">
-            <a:schemeClr val="accent1"/>
-          </a:lnRef>
-          <a:fillRef idx="3">
-            <a:schemeClr val="accent1"/>
-          </a:fillRef>
-          <a:effectRef idx="2">
-            <a:schemeClr val="accent1"/>
-          </a:effectRef>
-          <a:fontRef idx="minor">
-            <a:schemeClr val="lt1"/>
-          </a:fontRef>
-        </p:style>
-        <p:txBody>
-          <a:bodyPr rtlCol="0" anchor="ctr"/>
-          <a:lstStyle/>
-          <a:p>
-            <a:pPr algn="ctr"/>
-          </a:p>
-        </p:txBody>
-      </p:sp>
-      <p:sp>
-        <p:nvSpPr>
-          <p:cNvPr id="20" name="Rounded Rectangle 19"/>
-          <p:cNvSpPr/>
-          <p:nvPr/>
-        </p:nvSpPr>
-        <p:spPr>
-          <a:xfrm>
-            <a:off x="5784038" y="1033272"/>
-            <a:ext cx="123444" cy="457200"/>
-          </a:xfrm>
-          <a:prstGeom prst="roundRect">
-            <a:avLst>
-              <a:gd name="adj" fmla="val 50000"/>
-            </a:avLst>
-          </a:prstGeom>
-          <a:solidFill>
-            <a:srgbClr val="FDFCF8"/>
-          </a:solidFill>
-          <a:ln>
-            <a:noFill/>
-          </a:ln>
-          <a:effectLst/>
-        </p:spPr>
-        <p:style>
-          <a:lnRef idx="1">
-            <a:schemeClr val="accent1"/>
-          </a:lnRef>
-          <a:fillRef idx="3">
-            <a:schemeClr val="accent1"/>
-          </a:fillRef>
-          <a:effectRef idx="2">
-            <a:schemeClr val="accent1"/>
-          </a:effectRef>
-          <a:fontRef idx="minor">
-            <a:schemeClr val="lt1"/>
-          </a:fontRef>
-        </p:style>
-        <p:txBody>
-          <a:bodyPr rtlCol="0" anchor="ctr"/>
-          <a:lstStyle/>
-          <a:p>
-            <a:pPr algn="ctr"/>
-          </a:p>
-        </p:txBody>
-      </p:sp>
-      <p:sp>
-        <p:nvSpPr>
-          <p:cNvPr id="21" name="Rounded Rectangle 20"/>
-          <p:cNvSpPr/>
-          <p:nvPr/>
-        </p:nvSpPr>
-        <p:spPr>
-          <a:xfrm>
-            <a:off x="5955030" y="960120"/>
-            <a:ext cx="123444" cy="603504"/>
-          </a:xfrm>
-          <a:prstGeom prst="roundRect">
-            <a:avLst>
-              <a:gd name="adj" fmla="val 50000"/>
-            </a:avLst>
-          </a:prstGeom>
-          <a:solidFill>
-            <a:srgbClr val="FA9E56"/>
-          </a:solidFill>
-          <a:ln>
-            <a:noFill/>
-          </a:ln>
-          <a:effectLst/>
-        </p:spPr>
-        <p:style>
-          <a:lnRef idx="1">
-            <a:schemeClr val="accent1"/>
-          </a:lnRef>
-          <a:fillRef idx="3">
-            <a:schemeClr val="accent1"/>
-          </a:fillRef>
-          <a:effectRef idx="2">
-            <a:schemeClr val="accent1"/>
-          </a:effectRef>
-          <a:fontRef idx="minor">
-            <a:schemeClr val="lt1"/>
-          </a:fontRef>
-        </p:style>
-        <p:txBody>
-          <a:bodyPr rtlCol="0" anchor="ctr"/>
-          <a:lstStyle/>
-          <a:p>
-            <a:pPr algn="ctr"/>
-          </a:p>
-        </p:txBody>
-      </p:sp>
-      <p:sp>
-        <p:nvSpPr>
-          <p:cNvPr id="22" name="Rounded Rectangle 21"/>
-          <p:cNvSpPr/>
-          <p:nvPr/>
-        </p:nvSpPr>
-        <p:spPr>
-          <a:xfrm>
-            <a:off x="6126022" y="1024128"/>
-            <a:ext cx="123444" cy="475488"/>
-          </a:xfrm>
-          <a:prstGeom prst="roundRect">
-            <a:avLst>
-              <a:gd name="adj" fmla="val 50000"/>
-            </a:avLst>
-          </a:prstGeom>
-          <a:solidFill>
-            <a:srgbClr val="FDFCF8"/>
-          </a:solidFill>
-          <a:ln>
-            <a:noFill/>
-          </a:ln>
-          <a:effectLst/>
-        </p:spPr>
-        <p:style>
-          <a:lnRef idx="1">
-            <a:schemeClr val="accent1"/>
-          </a:lnRef>
-          <a:fillRef idx="3">
-            <a:schemeClr val="accent1"/>
-          </a:fillRef>
-          <a:effectRef idx="2">
-            <a:schemeClr val="accent1"/>
-          </a:effectRef>
-          <a:fontRef idx="minor">
-            <a:schemeClr val="lt1"/>
-          </a:fontRef>
-        </p:style>
-        <p:txBody>
-          <a:bodyPr rtlCol="0" anchor="ctr"/>
-          <a:lstStyle/>
-          <a:p>
-            <a:pPr algn="ctr"/>
-          </a:p>
-        </p:txBody>
-      </p:sp>
-      <p:sp>
-        <p:nvSpPr>
-          <p:cNvPr id="23" name="Rounded Rectangle 22"/>
-          <p:cNvSpPr/>
-          <p:nvPr/>
-        </p:nvSpPr>
-        <p:spPr>
-          <a:xfrm>
-            <a:off x="6297014" y="1106424"/>
-            <a:ext cx="123444" cy="310896"/>
-          </a:xfrm>
-          <a:prstGeom prst="roundRect">
-            <a:avLst>
-              <a:gd name="adj" fmla="val 50000"/>
-            </a:avLst>
-          </a:prstGeom>
-          <a:solidFill>
-            <a:srgbClr val="FDFCF8"/>
-          </a:solidFill>
-          <a:ln>
-            <a:noFill/>
-          </a:ln>
-          <a:effectLst/>
-        </p:spPr>
-        <p:style>
-          <a:lnRef idx="1">
-            <a:schemeClr val="accent1"/>
-          </a:lnRef>
-          <a:fillRef idx="3">
-            <a:schemeClr val="accent1"/>
-          </a:fillRef>
-          <a:effectRef idx="2">
-            <a:schemeClr val="accent1"/>
-          </a:effectRef>
-          <a:fontRef idx="minor">
-            <a:schemeClr val="lt1"/>
-          </a:fontRef>
-        </p:style>
-        <p:txBody>
-          <a:bodyPr rtlCol="0" anchor="ctr"/>
-          <a:lstStyle/>
-          <a:p>
-            <a:pPr algn="ctr"/>
-          </a:p>
-        </p:txBody>
-      </p:sp>
-      <p:sp>
-        <p:nvSpPr>
-          <p:cNvPr id="24" name="TextBox 23"/>
+      <p:pic>
+        <p:nvPicPr>
+          <p:cNvPr id="17" name="Picture 16" descr="appicon.png"/>
+          <p:cNvPicPr>
+            <a:picLocks noChangeAspect="1"/>
+          </p:cNvPicPr>
+          <p:nvPr/>
+        </p:nvPicPr>
+        <p:blipFill>
+          <a:blip r:embed="rId2"/>
+          <a:stretch>
+            <a:fillRect/>
+          </a:stretch>
+        </p:blipFill>
+        <p:spPr>
+          <a:xfrm>
+            <a:off x="5272887" y="420624"/>
+            <a:ext cx="1645920" cy="1645920"/>
+          </a:xfrm>
+          <a:prstGeom prst="rect">
+            <a:avLst/>
+          </a:prstGeom>
+        </p:spPr>
+      </p:pic>
+      <p:sp>
+        <p:nvSpPr>
+          <p:cNvPr id="18" name="TextBox 17"/>
           <p:cNvSpPr txBox="1"/>
           <p:nvPr/>
         </p:nvSpPr>
@@ -4144,7 +3846,7 @@
       </p:sp>
       <p:sp>
         <p:nvSpPr>
-          <p:cNvPr id="25" name="TextBox 24"/>
+          <p:cNvPr id="19" name="TextBox 18"/>
           <p:cNvSpPr txBox="1"/>
           <p:nvPr/>
         </p:nvSpPr>
@@ -4186,7 +3888,7 @@
       </p:sp>
       <p:sp>
         <p:nvSpPr>
-          <p:cNvPr id="26" name="Rounded Rectangle 25"/>
+          <p:cNvPr id="20" name="Rounded Rectangle 19"/>
           <p:cNvSpPr/>
           <p:nvPr/>
         </p:nvSpPr>
@@ -4234,7 +3936,7 @@
       </p:sp>
       <p:sp>
         <p:nvSpPr>
-          <p:cNvPr id="27" name="TextBox 26"/>
+          <p:cNvPr id="21" name="TextBox 20"/>
           <p:cNvSpPr txBox="1"/>
           <p:nvPr/>
         </p:nvSpPr>
@@ -4276,7 +3978,7 @@
       </p:sp>
       <p:sp>
         <p:nvSpPr>
-          <p:cNvPr id="28" name="TextBox 27"/>
+          <p:cNvPr id="22" name="TextBox 21"/>
           <p:cNvSpPr txBox="1"/>
           <p:nvPr/>
         </p:nvSpPr>
@@ -4318,7 +4020,7 @@
       </p:sp>
       <p:sp>
         <p:nvSpPr>
-          <p:cNvPr id="29" name="Rounded Rectangle 28"/>
+          <p:cNvPr id="23" name="Rounded Rectangle 22"/>
           <p:cNvSpPr/>
           <p:nvPr/>
         </p:nvSpPr>
@@ -4366,7 +4068,7 @@
       </p:sp>
       <p:sp>
         <p:nvSpPr>
-          <p:cNvPr id="30" name="TextBox 29"/>
+          <p:cNvPr id="24" name="TextBox 23"/>
           <p:cNvSpPr txBox="1"/>
           <p:nvPr/>
         </p:nvSpPr>
@@ -4408,7 +4110,7 @@
       </p:sp>
       <p:sp>
         <p:nvSpPr>
-          <p:cNvPr id="31" name="TextBox 30"/>
+          <p:cNvPr id="25" name="TextBox 24"/>
           <p:cNvSpPr txBox="1"/>
           <p:nvPr/>
         </p:nvSpPr>
@@ -4450,7 +4152,7 @@
       </p:sp>
       <p:sp>
         <p:nvSpPr>
-          <p:cNvPr id="32" name="Rounded Rectangle 31"/>
+          <p:cNvPr id="26" name="Rounded Rectangle 25"/>
           <p:cNvSpPr/>
           <p:nvPr/>
         </p:nvSpPr>
@@ -4498,7 +4200,7 @@
       </p:sp>
       <p:sp>
         <p:nvSpPr>
-          <p:cNvPr id="33" name="TextBox 32"/>
+          <p:cNvPr id="27" name="TextBox 26"/>
           <p:cNvSpPr txBox="1"/>
           <p:nvPr/>
         </p:nvSpPr>
@@ -4540,7 +4242,7 @@
       </p:sp>
       <p:sp>
         <p:nvSpPr>
-          <p:cNvPr id="34" name="TextBox 33"/>
+          <p:cNvPr id="28" name="TextBox 27"/>
           <p:cNvSpPr txBox="1"/>
           <p:nvPr/>
         </p:nvSpPr>
@@ -4582,13 +4284,13 @@
       </p:sp>
       <p:sp>
         <p:nvSpPr>
-          <p:cNvPr id="35" name="Rounded Rectangle 34"/>
-          <p:cNvSpPr/>
-          <p:nvPr/>
-        </p:nvSpPr>
-        <p:spPr>
-          <a:xfrm>
-            <a:off x="3357219" y="5413248"/>
+          <p:cNvPr id="29" name="Rounded Rectangle 28"/>
+          <p:cNvSpPr/>
+          <p:nvPr/>
+        </p:nvSpPr>
+        <p:spPr>
+          <a:xfrm>
+            <a:off x="2141067" y="5413248"/>
             <a:ext cx="1714500" cy="292608"/>
           </a:xfrm>
           <a:prstGeom prst="roundRect">
@@ -4632,21 +4334,21 @@
                 </a:solidFill>
                 <a:latin typeface="JetBrains Mono"/>
               </a:rPr>
-              <a:t>ЗАЩИТА ПРОЕКТА · 2026</a:t>
-            </a:r>
-          </a:p>
-        </p:txBody>
-      </p:sp>
-      <p:sp>
-        <p:nvSpPr>
-          <p:cNvPr id="36" name="Rounded Rectangle 35"/>
-          <p:cNvSpPr/>
-          <p:nvPr/>
-        </p:nvSpPr>
-        <p:spPr>
-          <a:xfrm>
-            <a:off x="5172303" y="5413248"/>
-            <a:ext cx="891540" cy="292608"/>
+              <a:t>PIZZA PITCH · SKO HUB</a:t>
+            </a:r>
+          </a:p>
+        </p:txBody>
+      </p:sp>
+      <p:sp>
+        <p:nvSpPr>
+          <p:cNvPr id="30" name="Rounded Rectangle 29"/>
+          <p:cNvSpPr/>
+          <p:nvPr/>
+        </p:nvSpPr>
+        <p:spPr>
+          <a:xfrm>
+            <a:off x="3956151" y="5413248"/>
+            <a:ext cx="2400300" cy="292608"/>
           </a:xfrm>
           <a:prstGeom prst="roundRect">
             <a:avLst>
@@ -4689,21 +4391,21 @@
                 </a:solidFill>
                 <a:latin typeface="JetBrains Mono"/>
               </a:rPr>
-              <a:t>MACOS 14+</a:t>
-            </a:r>
-          </a:p>
-        </p:txBody>
-      </p:sp>
-      <p:sp>
-        <p:nvSpPr>
-          <p:cNvPr id="37" name="Rounded Rectangle 36"/>
-          <p:cNvSpPr/>
-          <p:nvPr/>
-        </p:nvSpPr>
-        <p:spPr>
-          <a:xfrm>
-            <a:off x="6164427" y="5413248"/>
-            <a:ext cx="891540" cy="292608"/>
+              <a:t>16 ОКТЯБРЯ 2026 · ПЕТРОПАВЛОВСК</a:t>
+            </a:r>
+          </a:p>
+        </p:txBody>
+      </p:sp>
+      <p:sp>
+        <p:nvSpPr>
+          <p:cNvPr id="31" name="Rounded Rectangle 30"/>
+          <p:cNvSpPr/>
+          <p:nvPr/>
+        </p:nvSpPr>
+        <p:spPr>
+          <a:xfrm>
+            <a:off x="6457035" y="5413248"/>
+            <a:ext cx="1028700" cy="292608"/>
           </a:xfrm>
           <a:prstGeom prst="roundRect">
             <a:avLst>
@@ -4746,21 +4448,21 @@
                 </a:solidFill>
                 <a:latin typeface="JetBrains Mono"/>
               </a:rPr>
-              <a:t>11 ЯЗЫКОВ</a:t>
-            </a:r>
-          </a:p>
-        </p:txBody>
-      </p:sp>
-      <p:sp>
-        <p:nvSpPr>
-          <p:cNvPr id="38" name="Rounded Rectangle 37"/>
-          <p:cNvSpPr/>
-          <p:nvPr/>
-        </p:nvSpPr>
-        <p:spPr>
-          <a:xfrm>
-            <a:off x="7156551" y="5413248"/>
-            <a:ext cx="1097280" cy="292608"/>
+              <a:t>ГОТОВЫЙ MVP</a:t>
+            </a:r>
+          </a:p>
+        </p:txBody>
+      </p:sp>
+      <p:sp>
+        <p:nvSpPr>
+          <p:cNvPr id="32" name="Rounded Rectangle 31"/>
+          <p:cNvSpPr/>
+          <p:nvPr/>
+        </p:nvSpPr>
+        <p:spPr>
+          <a:xfrm>
+            <a:off x="7586319" y="5413248"/>
+            <a:ext cx="891540" cy="292608"/>
           </a:xfrm>
           <a:prstGeom prst="roundRect">
             <a:avLst>
@@ -4803,20 +4505,77 @@
                 </a:solidFill>
                 <a:latin typeface="JetBrains Mono"/>
               </a:rPr>
-              <a:t>ОТКРЫТЫЙ КОД</a:t>
-            </a:r>
-          </a:p>
-        </p:txBody>
-      </p:sp>
-      <p:sp>
-        <p:nvSpPr>
-          <p:cNvPr id="39" name="Rounded Rectangle 38"/>
-          <p:cNvSpPr/>
-          <p:nvPr/>
-        </p:nvSpPr>
-        <p:spPr>
-          <a:xfrm>
-            <a:off x="8354415" y="5413248"/>
+              <a:t>MACOS 14+</a:t>
+            </a:r>
+          </a:p>
+        </p:txBody>
+      </p:sp>
+      <p:sp>
+        <p:nvSpPr>
+          <p:cNvPr id="33" name="Rounded Rectangle 32"/>
+          <p:cNvSpPr/>
+          <p:nvPr/>
+        </p:nvSpPr>
+        <p:spPr>
+          <a:xfrm>
+            <a:off x="8578443" y="5413248"/>
+            <a:ext cx="891540" cy="292608"/>
+          </a:xfrm>
+          <a:prstGeom prst="roundRect">
+            <a:avLst>
+              <a:gd name="adj" fmla="val 50000"/>
+            </a:avLst>
+          </a:prstGeom>
+          <a:solidFill>
+            <a:srgbClr val="FDFCF8"/>
+          </a:solidFill>
+          <a:ln w="28575">
+            <a:solidFill>
+              <a:srgbClr val="1C2447"/>
+            </a:solidFill>
+          </a:ln>
+          <a:effectLst/>
+        </p:spPr>
+        <p:style>
+          <a:lnRef idx="1">
+            <a:schemeClr val="accent1"/>
+          </a:lnRef>
+          <a:fillRef idx="3">
+            <a:schemeClr val="accent1"/>
+          </a:fillRef>
+          <a:effectRef idx="2">
+            <a:schemeClr val="accent1"/>
+          </a:effectRef>
+          <a:fontRef idx="minor">
+            <a:schemeClr val="lt1"/>
+          </a:fontRef>
+        </p:style>
+        <p:txBody>
+          <a:bodyPr rtlCol="0" anchor="ctr" wrap="none" lIns="0" rIns="0" tIns="0" bIns="0"/>
+          <a:lstStyle/>
+          <a:p>
+            <a:pPr algn="ctr"/>
+            <a:r>
+              <a:rPr sz="800" b="1">
+                <a:solidFill>
+                  <a:srgbClr val="1C2447"/>
+                </a:solidFill>
+                <a:latin typeface="JetBrains Mono"/>
+              </a:rPr>
+              <a:t>11 ЯЗЫКОВ</a:t>
+            </a:r>
+          </a:p>
+        </p:txBody>
+      </p:sp>
+      <p:sp>
+        <p:nvSpPr>
+          <p:cNvPr id="34" name="Rounded Rectangle 33"/>
+          <p:cNvSpPr/>
+          <p:nvPr/>
+        </p:nvSpPr>
+        <p:spPr>
+          <a:xfrm>
+            <a:off x="9570567" y="5413248"/>
             <a:ext cx="480060" cy="292608"/>
           </a:xfrm>
           <a:prstGeom prst="roundRect">
@@ -6514,7 +6273,7 @@
                 </a:solidFill>
                 <a:latin typeface="Rubik"/>
               </a:rPr>
-              <a:t>Удержать нулевую цену. </a:t>
+              <a:t>Вывести на рынок. </a:t>
             </a:r>
             <a:r>
               <a:rPr sz="900" b="0" i="0">
@@ -6523,7 +6282,7 @@
                 </a:solidFill>
                 <a:latin typeface="Rubik"/>
               </a:rPr>
-              <a:t>Бесплатное ядро и открытый код как основа продукта, а не как акция.</a:t>
+              <a:t>Лендинг, первые 1 000 пользователей и грант GitHub на AI-модели.</a:t>
             </a:r>
           </a:p>
         </p:txBody>
@@ -11720,7 +11479,7 @@
                 </a:solidFill>
                 <a:latin typeface="Rubik"/>
               </a:rPr>
-              <a:t>План найма: продуктовый маркетинг, продажи и поддержка в 2026 году.</a:t>
+              <a:t>План найма: продуктовый маркетинг, продажи и поддержка в 2027 году.</a:t>
             </a:r>
           </a:p>
         </p:txBody>
@@ -11852,7 +11611,7 @@
                 </a:solidFill>
                 <a:latin typeface="Unbounded"/>
               </a:rPr>
-              <a:t>10 000</a:t>
+              <a:t>5 000</a:t>
             </a:r>
           </a:p>
         </p:txBody>
@@ -11894,7 +11653,7 @@
                 </a:solidFill>
                 <a:latin typeface="JetBrains Mono"/>
               </a:rPr>
-              <a:t>ПОЛЬЗОВАТЕЛЕЙ К КОНЦУ ГОДА</a:t>
+              <a:t>ПОЛЬЗОВАТЕЛЕЙ ЗА ГОД</a:t>
             </a:r>
           </a:p>
         </p:txBody>
@@ -12230,7 +11989,7 @@
                 </a:solidFill>
                 <a:latin typeface="Unbounded"/>
               </a:rPr>
-              <a:t>≈ 1,5 млн</a:t>
+              <a:t>≈ 0,7 млн</a:t>
             </a:r>
           </a:p>
         </p:txBody>
@@ -12314,7 +12073,7 @@
                 </a:solidFill>
                 <a:latin typeface="Rubik"/>
               </a:rPr>
-              <a:t>Это эквивалент примерно 800 полных ставок в год — время, которое регион получает без единого тенге бюджетных затрат.</a:t>
+              <a:t>Это эквивалент примерно 400 полных ставок в год — время, которое регион получает без единого тенге бюджетных затрат.</a:t>
             </a:r>
           </a:p>
         </p:txBody>
@@ -13155,7 +12914,7 @@
                 </a:solidFill>
                 <a:latin typeface="Rubik"/>
               </a:rPr>
-              <a:t>Пять этапов на 15 месяцев. Первый уже закрыт, остальные ложатся на работающий продукт, а не на прототип.</a:t>
+              <a:t>Пять этапов на 12 месяцев. Первый уже закрыт, остальные опираются на работающий продукт, а не на прототип.</a:t>
             </a:r>
           </a:p>
         </p:txBody>
@@ -13245,7 +13004,7 @@
                 </a:solidFill>
                 <a:latin typeface="Unbounded"/>
               </a:rPr>
-              <a:t>Q4 2025</a:t>
+              <a:t>Q4 2026</a:t>
             </a:r>
           </a:p>
         </p:txBody>
@@ -13390,7 +13149,7 @@
                 </a:solidFill>
                 <a:latin typeface="Rubik"/>
               </a:rPr>
-              <a:t>Релиз 2.0: системный звук</a:t>
+              <a:t>Релиз 2.0 выпущен</a:t>
             </a:r>
           </a:p>
         </p:txBody>
@@ -13478,7 +13237,7 @@
                 </a:solidFill>
                 <a:latin typeface="Rubik"/>
               </a:rPr>
-              <a:t>Транскрипция файлов</a:t>
+              <a:t>Системный звук и файлы</a:t>
             </a:r>
           </a:p>
         </p:txBody>
@@ -13566,7 +13325,7 @@
                 </a:solidFill>
                 <a:latin typeface="Rubik"/>
               </a:rPr>
-              <a:t>История транскрипций</a:t>
+              <a:t>История и 11 языков</a:t>
             </a:r>
           </a:p>
         </p:txBody>
@@ -13654,7 +13413,7 @@
                 </a:solidFill>
                 <a:latin typeface="Rubik"/>
               </a:rPr>
-              <a:t>11 языков интерфейса</a:t>
+              <a:t>Сборки: ARM, Intel, универсальная</a:t>
             </a:r>
           </a:p>
         </p:txBody>
@@ -13744,7 +13503,7 @@
                 </a:solidFill>
                 <a:latin typeface="Unbounded"/>
               </a:rPr>
-              <a:t>Q1 2026</a:t>
+              <a:t>Q1 2027</a:t>
             </a:r>
           </a:p>
         </p:txBody>
@@ -13889,7 +13648,7 @@
                 </a:solidFill>
                 <a:latin typeface="Rubik"/>
               </a:rPr>
-              <a:t>Пилот: 1 000 установок</a:t>
+              <a:t>Лендинг продукта</a:t>
             </a:r>
           </a:p>
         </p:txBody>
@@ -13977,7 +13736,7 @@
                 </a:solidFill>
                 <a:latin typeface="Rubik"/>
               </a:rPr>
-              <a:t>Метрики и обратная связь</a:t>
+              <a:t>Заявка на грант GitHub</a:t>
             </a:r>
           </a:p>
         </p:txBody>
@@ -14065,7 +13824,7 @@
                 </a:solidFill>
                 <a:latin typeface="Rubik"/>
               </a:rPr>
-              <a:t>Подготовка Pro-версии</a:t>
+              <a:t>Первые 1 000 установок</a:t>
             </a:r>
           </a:p>
         </p:txBody>
@@ -14153,7 +13912,7 @@
                 </a:solidFill>
                 <a:latin typeface="Rubik"/>
               </a:rPr>
-              <a:t>Стабилизация macOS 26</a:t>
+              <a:t>Обратная связь и метрики</a:t>
             </a:r>
           </a:p>
         </p:txBody>
@@ -14243,7 +14002,7 @@
                 </a:solidFill>
                 <a:latin typeface="Unbounded"/>
               </a:rPr>
-              <a:t>Q2 2026</a:t>
+              <a:t>Q2 2027</a:t>
             </a:r>
           </a:p>
         </p:txBody>
@@ -14685,7 +14444,7 @@
                 </a:solidFill>
                 <a:latin typeface="Unbounded"/>
               </a:rPr>
-              <a:t>Q3 2026</a:t>
+              <a:t>Q3 2027</a:t>
             </a:r>
           </a:p>
         </p:txBody>
@@ -15127,7 +14886,7 @@
                 </a:solidFill>
                 <a:latin typeface="Unbounded"/>
               </a:rPr>
-              <a:t>Q4 2026</a:t>
+              <a:t>Q4 2027</a:t>
             </a:r>
           </a:p>
         </p:txBody>
@@ -15932,7 +15691,7 @@
                 </a:solidFill>
                 <a:latin typeface="Rubik"/>
               </a:rPr>
-              <a:t>Бюджет — только на вывод на рынок. </a:t>
+              <a:t>Финансирование под контролем. </a:t>
             </a:r>
             <a:r>
               <a:rPr sz="850" b="0" i="0">
@@ -15941,7 +15700,7 @@
                 </a:solidFill>
                 <a:latin typeface="Rubik"/>
               </a:rPr>
-              <a:t>Разработка ядра оплачена временем основателя.</a:t>
+              <a:t>Грант GitHub покрывает смету — инвестиции не нужны.</a:t>
             </a:r>
           </a:p>
         </p:txBody>
@@ -16830,7 +16589,7 @@
                 </a:solidFill>
                 <a:latin typeface="Unbounded"/>
               </a:rPr>
-              <a:t>10 000</a:t>
+              <a:t>5 000</a:t>
             </a:r>
           </a:p>
         </p:txBody>
@@ -16962,7 +16721,7 @@
                 </a:solidFill>
                 <a:latin typeface="Unbounded"/>
               </a:rPr>
-              <a:t>500</a:t>
+              <a:t>300</a:t>
             </a:r>
           </a:p>
         </p:txBody>
@@ -17094,7 +16853,7 @@
                 </a:solidFill>
                 <a:latin typeface="Unbounded"/>
               </a:rPr>
-              <a:t>3</a:t>
+              <a:t>$10 000</a:t>
             </a:r>
           </a:p>
         </p:txBody>
@@ -17136,7 +16895,7 @@
                 </a:solidFill>
                 <a:latin typeface="JetBrains Mono"/>
               </a:rPr>
-              <a:t>КОРПОРАТИВНЫХ ВНЕДРЕНИЯ</a:t>
+              <a:t>ГРАНТ GITHUB ДЛЯ СТАРТАПОВ</a:t>
             </a:r>
           </a:p>
         </p:txBody>
@@ -17226,7 +16985,7 @@
                 </a:solidFill>
                 <a:latin typeface="Unbounded"/>
               </a:rPr>
-              <a:t>1,5 млн</a:t>
+              <a:t>0,7 млн</a:t>
             </a:r>
           </a:p>
         </p:txBody>
@@ -17451,7 +17210,7 @@
                 </a:solidFill>
                 <a:latin typeface="Rubik"/>
               </a:rPr>
-              <a:t>Не менее 10 000 активных установок за 12 месяцев и не менее 1 000 в первом квартале.</a:t>
+              <a:t>Не менее 5 000 активных установок за 12 месяцев и не менее 1 000 в первом квартале.</a:t>
             </a:r>
           </a:p>
         </p:txBody>
@@ -17721,7 +17480,7 @@
                 </a:solidFill>
                 <a:latin typeface="Rubik"/>
               </a:rPr>
-              <a:t>Внедрения. </a:t>
+              <a:t>Финансирование. </a:t>
             </a:r>
             <a:r>
               <a:rPr sz="850" b="0" i="0">
@@ -17730,7 +17489,7 @@
                 </a:solidFill>
                 <a:latin typeface="Rubik"/>
               </a:rPr>
-              <a:t>Три организации региона — вуз, IT-компания или госструктура — используют WhisperFly в ежедневной работе.</a:t>
+              <a:t>Грант GitHub для стартапов получен и покрывает смету на 6 месяцев — без внешних инвестиций.</a:t>
             </a:r>
           </a:p>
         </p:txBody>
@@ -18520,7 +18279,7 @@
                 </a:solidFill>
                 <a:latin typeface="Unbounded"/>
               </a:rPr>
-              <a:t>Смета на </a:t>
+              <a:t>Что нужно и </a:t>
             </a:r>
             <a:r>
               <a:rPr sz="2700" b="1" i="0">
@@ -18529,7 +18288,7 @@
                 </a:solidFill>
                 <a:latin typeface="Unbounded"/>
               </a:rPr>
-              <a:t>12 месяцев</a:t>
+              <a:t>откуда</a:t>
             </a:r>
           </a:p>
         </p:txBody>
@@ -18763,7 +18522,7 @@
                 </a:solidFill>
                 <a:latin typeface="JetBrains Mono"/>
               </a:rPr>
-              <a:t>200 000 ₸ × 12 мес</a:t>
+              <a:t>200 000 ₸ × 6 мес</a:t>
             </a:r>
           </a:p>
         </p:txBody>
@@ -18849,7 +18608,7 @@
                 </a:solidFill>
                 <a:latin typeface="JetBrains Mono"/>
               </a:rPr>
-              <a:t>2 400 000 ₸</a:t>
+              <a:t>1 200 000 ₸</a:t>
             </a:r>
           </a:p>
         </p:txBody>
@@ -18906,7 +18665,7 @@
         </p:nvSpPr>
         <p:spPr>
           <a:xfrm>
-            <a:off x="713232" y="2423160"/>
+            <a:off x="713232" y="2359152"/>
             <a:ext cx="3894059" cy="182880"/>
           </a:xfrm>
           <a:prstGeom prst="rect">
@@ -18935,14 +18694,56 @@
                 </a:solidFill>
                 <a:latin typeface="Rubik"/>
               </a:rPr>
-              <a:t>Маркетинг и вывод продукта на рынок</a:t>
-            </a:r>
-          </a:p>
-        </p:txBody>
-      </p:sp>
-      <p:sp>
-        <p:nvSpPr>
-          <p:cNvPr id="28" name="Rectangle 27"/>
+              <a:t>AI-модели и облачные API</a:t>
+            </a:r>
+          </a:p>
+        </p:txBody>
+      </p:sp>
+      <p:sp>
+        <p:nvSpPr>
+          <p:cNvPr id="28" name="TextBox 27"/>
+          <p:cNvSpPr txBox="1"/>
+          <p:nvPr/>
+        </p:nvSpPr>
+        <p:spPr>
+          <a:xfrm>
+            <a:off x="713232" y="2532888"/>
+            <a:ext cx="3894059" cy="164592"/>
+          </a:xfrm>
+          <a:prstGeom prst="rect">
+            <a:avLst/>
+          </a:prstGeom>
+          <a:noFill/>
+        </p:spPr>
+        <p:txBody>
+          <a:bodyPr wrap="square" lIns="0" rIns="0" tIns="0" bIns="0" anchor="t">
+            <a:spAutoFit/>
+          </a:bodyPr>
+          <a:lstStyle/>
+          <a:p>
+            <a:pPr algn="l">
+              <a:lnSpc>
+                <a:spcPct val="120000"/>
+              </a:lnSpc>
+              <a:spcAft>
+                <a:spcPts val="0"/>
+              </a:spcAft>
+            </a:pPr>
+            <a:r>
+              <a:rPr sz="700" b="0" i="0">
+                <a:solidFill>
+                  <a:srgbClr val="5A6180"/>
+                </a:solidFill>
+                <a:latin typeface="JetBrains Mono"/>
+              </a:rPr>
+              <a:t>$1 000 · уже оплачено</a:t>
+            </a:r>
+          </a:p>
+        </p:txBody>
+      </p:sp>
+      <p:sp>
+        <p:nvSpPr>
+          <p:cNvPr id="29" name="Rectangle 28"/>
           <p:cNvSpPr/>
           <p:nvPr/>
         </p:nvSpPr>
@@ -18986,7 +18787,7 @@
       </p:sp>
       <p:sp>
         <p:nvSpPr>
-          <p:cNvPr id="29" name="TextBox 28"/>
+          <p:cNvPr id="30" name="TextBox 29"/>
           <p:cNvSpPr txBox="1"/>
           <p:nvPr/>
         </p:nvSpPr>
@@ -19021,14 +18822,14 @@
                 </a:solidFill>
                 <a:latin typeface="JetBrains Mono"/>
               </a:rPr>
-              <a:t>600 000 ₸</a:t>
-            </a:r>
-          </a:p>
-        </p:txBody>
-      </p:sp>
-      <p:sp>
-        <p:nvSpPr>
-          <p:cNvPr id="30" name="Rectangle 29"/>
+              <a:t>530 000 ₸</a:t>
+            </a:r>
+          </a:p>
+        </p:txBody>
+      </p:sp>
+      <p:sp>
+        <p:nvSpPr>
+          <p:cNvPr id="31" name="Rectangle 30"/>
           <p:cNvSpPr/>
           <p:nvPr/>
         </p:nvSpPr>
@@ -19072,7 +18873,7 @@
       </p:sp>
       <p:sp>
         <p:nvSpPr>
-          <p:cNvPr id="31" name="TextBox 30"/>
+          <p:cNvPr id="32" name="TextBox 31"/>
           <p:cNvSpPr txBox="1"/>
           <p:nvPr/>
         </p:nvSpPr>
@@ -19107,14 +18908,14 @@
                 </a:solidFill>
                 <a:latin typeface="Rubik"/>
               </a:rPr>
-              <a:t>Тестовое оборудование и устройства</a:t>
-            </a:r>
-          </a:p>
-        </p:txBody>
-      </p:sp>
-      <p:sp>
-        <p:nvSpPr>
-          <p:cNvPr id="32" name="Rectangle 31"/>
+              <a:t>Продвижение лендинга и первые установки</a:t>
+            </a:r>
+          </a:p>
+        </p:txBody>
+      </p:sp>
+      <p:sp>
+        <p:nvSpPr>
+          <p:cNvPr id="33" name="Rectangle 32"/>
           <p:cNvSpPr/>
           <p:nvPr/>
         </p:nvSpPr>
@@ -19158,7 +18959,7 @@
       </p:sp>
       <p:sp>
         <p:nvSpPr>
-          <p:cNvPr id="33" name="TextBox 32"/>
+          <p:cNvPr id="34" name="TextBox 33"/>
           <p:cNvSpPr txBox="1"/>
           <p:nvPr/>
         </p:nvSpPr>
@@ -19193,14 +18994,14 @@
                 </a:solidFill>
                 <a:latin typeface="JetBrains Mono"/>
               </a:rPr>
-              <a:t>500 000 ₸</a:t>
-            </a:r>
-          </a:p>
-        </p:txBody>
-      </p:sp>
-      <p:sp>
-        <p:nvSpPr>
-          <p:cNvPr id="34" name="Rectangle 33"/>
+              <a:t>250 000 ₸</a:t>
+            </a:r>
+          </a:p>
+        </p:txBody>
+      </p:sp>
+      <p:sp>
+        <p:nvSpPr>
+          <p:cNvPr id="35" name="Rectangle 34"/>
           <p:cNvSpPr/>
           <p:nvPr/>
         </p:nvSpPr>
@@ -19244,7 +19045,7 @@
       </p:sp>
       <p:sp>
         <p:nvSpPr>
-          <p:cNvPr id="35" name="TextBox 34"/>
+          <p:cNvPr id="36" name="TextBox 35"/>
           <p:cNvSpPr txBox="1"/>
           <p:nvPr/>
         </p:nvSpPr>
@@ -19279,14 +19080,14 @@
                 </a:solidFill>
                 <a:latin typeface="Rubik"/>
               </a:rPr>
-              <a:t>Облачные API распознавания и AI-обработки</a:t>
-            </a:r>
-          </a:p>
-        </p:txBody>
-      </p:sp>
-      <p:sp>
-        <p:nvSpPr>
-          <p:cNvPr id="36" name="Rectangle 35"/>
+              <a:t>Домен, хостинг и аналитика лендинга</a:t>
+            </a:r>
+          </a:p>
+        </p:txBody>
+      </p:sp>
+      <p:sp>
+        <p:nvSpPr>
+          <p:cNvPr id="37" name="Rectangle 36"/>
           <p:cNvSpPr/>
           <p:nvPr/>
         </p:nvSpPr>
@@ -19330,7 +19131,7 @@
       </p:sp>
       <p:sp>
         <p:nvSpPr>
-          <p:cNvPr id="37" name="TextBox 36"/>
+          <p:cNvPr id="38" name="TextBox 37"/>
           <p:cNvSpPr txBox="1"/>
           <p:nvPr/>
         </p:nvSpPr>
@@ -19365,14 +19166,14 @@
                 </a:solidFill>
                 <a:latin typeface="JetBrains Mono"/>
               </a:rPr>
-              <a:t>360 000 ₸</a:t>
-            </a:r>
-          </a:p>
-        </p:txBody>
-      </p:sp>
-      <p:sp>
-        <p:nvSpPr>
-          <p:cNvPr id="38" name="Rectangle 37"/>
+              <a:t>60 000 ₸</a:t>
+            </a:r>
+          </a:p>
+        </p:txBody>
+      </p:sp>
+      <p:sp>
+        <p:nvSpPr>
+          <p:cNvPr id="39" name="Rectangle 38"/>
           <p:cNvSpPr/>
           <p:nvPr/>
         </p:nvSpPr>
@@ -19416,13 +19217,13 @@
       </p:sp>
       <p:sp>
         <p:nvSpPr>
-          <p:cNvPr id="39" name="TextBox 38"/>
+          <p:cNvPr id="40" name="TextBox 39"/>
           <p:cNvSpPr txBox="1"/>
           <p:nvPr/>
         </p:nvSpPr>
         <p:spPr>
           <a:xfrm>
-            <a:off x="713232" y="3685032"/>
+            <a:off x="713232" y="3621024"/>
             <a:ext cx="3894059" cy="182880"/>
           </a:xfrm>
           <a:prstGeom prst="rect">
@@ -19451,14 +19252,56 @@
                 </a:solidFill>
                 <a:latin typeface="Rubik"/>
               </a:rPr>
-              <a:t>Юридические и бухгалтерские услуги</a:t>
-            </a:r>
-          </a:p>
-        </p:txBody>
-      </p:sp>
-      <p:sp>
-        <p:nvSpPr>
-          <p:cNvPr id="40" name="Rectangle 39"/>
+              <a:t>Apple Developer Program</a:t>
+            </a:r>
+          </a:p>
+        </p:txBody>
+      </p:sp>
+      <p:sp>
+        <p:nvSpPr>
+          <p:cNvPr id="41" name="TextBox 40"/>
+          <p:cNvSpPr txBox="1"/>
+          <p:nvPr/>
+        </p:nvSpPr>
+        <p:spPr>
+          <a:xfrm>
+            <a:off x="713232" y="3794760"/>
+            <a:ext cx="3894059" cy="164592"/>
+          </a:xfrm>
+          <a:prstGeom prst="rect">
+            <a:avLst/>
+          </a:prstGeom>
+          <a:noFill/>
+        </p:spPr>
+        <p:txBody>
+          <a:bodyPr wrap="square" lIns="0" rIns="0" tIns="0" bIns="0" anchor="t">
+            <a:spAutoFit/>
+          </a:bodyPr>
+          <a:lstStyle/>
+          <a:p>
+            <a:pPr algn="l">
+              <a:lnSpc>
+                <a:spcPct val="120000"/>
+              </a:lnSpc>
+              <a:spcAft>
+                <a:spcPts val="0"/>
+              </a:spcAft>
+            </a:pPr>
+            <a:r>
+              <a:rPr sz="700" b="0" i="0">
+                <a:solidFill>
+                  <a:srgbClr val="5A6180"/>
+                </a:solidFill>
+                <a:latin typeface="JetBrains Mono"/>
+              </a:rPr>
+              <a:t>$99 в год</a:t>
+            </a:r>
+          </a:p>
+        </p:txBody>
+      </p:sp>
+      <p:sp>
+        <p:nvSpPr>
+          <p:cNvPr id="42" name="Rectangle 41"/>
           <p:cNvSpPr/>
           <p:nvPr/>
         </p:nvSpPr>
@@ -19502,7 +19345,7 @@
       </p:sp>
       <p:sp>
         <p:nvSpPr>
-          <p:cNvPr id="41" name="TextBox 40"/>
+          <p:cNvPr id="43" name="TextBox 42"/>
           <p:cNvSpPr txBox="1"/>
           <p:nvPr/>
         </p:nvSpPr>
@@ -19537,14 +19380,14 @@
                 </a:solidFill>
                 <a:latin typeface="JetBrains Mono"/>
               </a:rPr>
-              <a:t>300 000 ₸</a:t>
-            </a:r>
-          </a:p>
-        </p:txBody>
-      </p:sp>
-      <p:sp>
-        <p:nvSpPr>
-          <p:cNvPr id="42" name="Rectangle 41"/>
+              <a:t>54 000 ₸</a:t>
+            </a:r>
+          </a:p>
+        </p:txBody>
+      </p:sp>
+      <p:sp>
+        <p:nvSpPr>
+          <p:cNvPr id="44" name="Rectangle 43"/>
           <p:cNvSpPr/>
           <p:nvPr/>
         </p:nvSpPr>
@@ -19588,7 +19431,7 @@
       </p:sp>
       <p:sp>
         <p:nvSpPr>
-          <p:cNvPr id="43" name="TextBox 42"/>
+          <p:cNvPr id="45" name="TextBox 44"/>
           <p:cNvSpPr txBox="1"/>
           <p:nvPr/>
         </p:nvSpPr>
@@ -19623,14 +19466,14 @@
                 </a:solidFill>
                 <a:latin typeface="Rubik"/>
               </a:rPr>
-              <a:t>Сертификаты и подпись приложения Apple</a:t>
-            </a:r>
-          </a:p>
-        </p:txBody>
-      </p:sp>
-      <p:sp>
-        <p:nvSpPr>
-          <p:cNvPr id="44" name="Rectangle 43"/>
+              <a:t>Резерв на непредвиденные расходы</a:t>
+            </a:r>
+          </a:p>
+        </p:txBody>
+      </p:sp>
+      <p:sp>
+        <p:nvSpPr>
+          <p:cNvPr id="46" name="Rectangle 45"/>
           <p:cNvSpPr/>
           <p:nvPr/>
         </p:nvSpPr>
@@ -19674,7 +19517,7 @@
       </p:sp>
       <p:sp>
         <p:nvSpPr>
-          <p:cNvPr id="45" name="TextBox 44"/>
+          <p:cNvPr id="47" name="TextBox 46"/>
           <p:cNvSpPr txBox="1"/>
           <p:nvPr/>
         </p:nvSpPr>
@@ -19709,27 +19552,27 @@
                 </a:solidFill>
                 <a:latin typeface="JetBrains Mono"/>
               </a:rPr>
-              <a:t>54 000 ₸</a:t>
-            </a:r>
-          </a:p>
-        </p:txBody>
-      </p:sp>
-      <p:sp>
-        <p:nvSpPr>
-          <p:cNvPr id="46" name="Rectangle 45"/>
+              <a:t>106 000 ₸</a:t>
+            </a:r>
+          </a:p>
+        </p:txBody>
+      </p:sp>
+      <p:sp>
+        <p:nvSpPr>
+          <p:cNvPr id="48" name="Rectangle 47"/>
           <p:cNvSpPr/>
           <p:nvPr/>
         </p:nvSpPr>
         <p:spPr>
           <a:xfrm>
             <a:off x="566928" y="4407408"/>
-            <a:ext cx="4113515" cy="420624"/>
-          </a:xfrm>
-          <a:prstGeom prst="rect">
-            <a:avLst/>
-          </a:prstGeom>
-          <a:solidFill>
-            <a:srgbClr val="FDFCF8"/>
+            <a:ext cx="6634703" cy="420624"/>
+          </a:xfrm>
+          <a:prstGeom prst="rect">
+            <a:avLst/>
+          </a:prstGeom>
+          <a:solidFill>
+            <a:srgbClr val="1C2447"/>
           </a:solidFill>
           <a:ln>
             <a:noFill/>
@@ -19760,14 +19603,14 @@
       </p:sp>
       <p:sp>
         <p:nvSpPr>
-          <p:cNvPr id="47" name="TextBox 46"/>
+          <p:cNvPr id="49" name="TextBox 48"/>
           <p:cNvSpPr txBox="1"/>
           <p:nvPr/>
         </p:nvSpPr>
         <p:spPr>
           <a:xfrm>
             <a:off x="713232" y="4526280"/>
-            <a:ext cx="3894059" cy="182880"/>
+            <a:ext cx="3894059" cy="201168"/>
           </a:xfrm>
           <a:prstGeom prst="rect">
             <a:avLst/>
@@ -19789,64 +19632,20 @@
               </a:spcAft>
             </a:pPr>
             <a:r>
-              <a:rPr sz="850" b="0" i="0">
-                <a:solidFill>
-                  <a:srgbClr val="1C2447"/>
-                </a:solidFill>
-                <a:latin typeface="Rubik"/>
-              </a:rPr>
-              <a:t>Резерв на непредвиденные расходы</a:t>
-            </a:r>
-          </a:p>
-        </p:txBody>
-      </p:sp>
-      <p:sp>
-        <p:nvSpPr>
-          <p:cNvPr id="48" name="Rectangle 47"/>
-          <p:cNvSpPr/>
-          <p:nvPr/>
-        </p:nvSpPr>
-        <p:spPr>
-          <a:xfrm>
-            <a:off x="4680443" y="4407408"/>
-            <a:ext cx="2521188" cy="420624"/>
-          </a:xfrm>
-          <a:prstGeom prst="rect">
-            <a:avLst/>
-          </a:prstGeom>
-          <a:solidFill>
-            <a:srgbClr val="FDFCF8"/>
-          </a:solidFill>
-          <a:ln>
-            <a:noFill/>
-          </a:ln>
-          <a:effectLst/>
-        </p:spPr>
-        <p:style>
-          <a:lnRef idx="1">
-            <a:schemeClr val="accent1"/>
-          </a:lnRef>
-          <a:fillRef idx="3">
-            <a:schemeClr val="accent1"/>
-          </a:fillRef>
-          <a:effectRef idx="2">
-            <a:schemeClr val="accent1"/>
-          </a:effectRef>
-          <a:fontRef idx="minor">
-            <a:schemeClr val="lt1"/>
-          </a:fontRef>
-        </p:style>
-        <p:txBody>
-          <a:bodyPr rtlCol="0" anchor="ctr"/>
-          <a:lstStyle/>
-          <a:p>
-            <a:pPr algn="ctr"/>
-          </a:p>
-        </p:txBody>
-      </p:sp>
-      <p:sp>
-        <p:nvSpPr>
-          <p:cNvPr id="49" name="TextBox 48"/>
+              <a:rPr sz="900" b="1" i="0">
+                <a:solidFill>
+                  <a:srgbClr val="FDFCF8"/>
+                </a:solidFill>
+                <a:latin typeface="Unbounded"/>
+              </a:rPr>
+              <a:t>Итого на 6 месяцев</a:t>
+            </a:r>
+          </a:p>
+        </p:txBody>
+      </p:sp>
+      <p:sp>
+        <p:nvSpPr>
+          <p:cNvPr id="50" name="TextBox 49"/>
           <p:cNvSpPr txBox="1"/>
           <p:nvPr/>
         </p:nvSpPr>
@@ -19875,36 +19674,315 @@
               </a:spcAft>
             </a:pPr>
             <a:r>
-              <a:rPr sz="850" b="1" i="0">
-                <a:solidFill>
-                  <a:srgbClr val="1C2447"/>
+              <a:rPr sz="900" b="1" i="0">
+                <a:solidFill>
+                  <a:srgbClr val="FDFCF8"/>
+                </a:solidFill>
+                <a:latin typeface="Unbounded"/>
+              </a:rPr>
+              <a:t>2 200 000 ₸</a:t>
+            </a:r>
+          </a:p>
+        </p:txBody>
+      </p:sp>
+      <p:sp>
+        <p:nvSpPr>
+          <p:cNvPr id="51" name="Rectangle 50"/>
+          <p:cNvSpPr/>
+          <p:nvPr/>
+        </p:nvSpPr>
+        <p:spPr>
+          <a:xfrm>
+            <a:off x="566928" y="1517904"/>
+            <a:ext cx="6634703" cy="3310128"/>
+          </a:xfrm>
+          <a:prstGeom prst="rect">
+            <a:avLst/>
+          </a:prstGeom>
+          <a:noFill/>
+          <a:ln w="28575">
+            <a:solidFill>
+              <a:srgbClr val="1C2447"/>
+            </a:solidFill>
+          </a:ln>
+          <a:effectLst/>
+        </p:spPr>
+        <p:style>
+          <a:lnRef idx="1">
+            <a:schemeClr val="accent1"/>
+          </a:lnRef>
+          <a:fillRef idx="3">
+            <a:schemeClr val="accent1"/>
+          </a:fillRef>
+          <a:effectRef idx="2">
+            <a:schemeClr val="accent1"/>
+          </a:effectRef>
+          <a:fontRef idx="minor">
+            <a:schemeClr val="lt1"/>
+          </a:fontRef>
+        </p:style>
+        <p:txBody>
+          <a:bodyPr rtlCol="0" anchor="ctr"/>
+          <a:lstStyle/>
+          <a:p>
+            <a:pPr algn="ctr"/>
+          </a:p>
+        </p:txBody>
+      </p:sp>
+      <p:sp>
+        <p:nvSpPr>
+          <p:cNvPr id="52" name="Rounded Rectangle 51"/>
+          <p:cNvSpPr/>
+          <p:nvPr/>
+        </p:nvSpPr>
+        <p:spPr>
+          <a:xfrm>
+            <a:off x="7384511" y="1517904"/>
+            <a:ext cx="4240256" cy="1920240"/>
+          </a:xfrm>
+          <a:prstGeom prst="roundRect">
+            <a:avLst>
+              <a:gd name="adj" fmla="val 9000"/>
+            </a:avLst>
+          </a:prstGeom>
+          <a:solidFill>
+            <a:srgbClr val="1B4BA9"/>
+          </a:solidFill>
+          <a:ln w="28575">
+            <a:solidFill>
+              <a:srgbClr val="1C2447"/>
+            </a:solidFill>
+          </a:ln>
+          <a:effectLst/>
+        </p:spPr>
+        <p:style>
+          <a:lnRef idx="1">
+            <a:schemeClr val="accent1"/>
+          </a:lnRef>
+          <a:fillRef idx="3">
+            <a:schemeClr val="accent1"/>
+          </a:fillRef>
+          <a:effectRef idx="2">
+            <a:schemeClr val="accent1"/>
+          </a:effectRef>
+          <a:fontRef idx="minor">
+            <a:schemeClr val="lt1"/>
+          </a:fontRef>
+        </p:style>
+        <p:txBody>
+          <a:bodyPr rtlCol="0" anchor="ctr"/>
+          <a:lstStyle/>
+          <a:p>
+            <a:pPr algn="ctr"/>
+          </a:p>
+        </p:txBody>
+      </p:sp>
+      <p:sp>
+        <p:nvSpPr>
+          <p:cNvPr id="53" name="Rounded Rectangle 52"/>
+          <p:cNvSpPr/>
+          <p:nvPr/>
+        </p:nvSpPr>
+        <p:spPr>
+          <a:xfrm>
+            <a:off x="7640543" y="1755648"/>
+            <a:ext cx="384048" cy="384048"/>
+          </a:xfrm>
+          <a:prstGeom prst="roundRect">
+            <a:avLst>
+              <a:gd name="adj" fmla="val 16000"/>
+            </a:avLst>
+          </a:prstGeom>
+          <a:solidFill>
+            <a:srgbClr val="FDFCF8"/>
+          </a:solidFill>
+          <a:ln w="28575">
+            <a:solidFill>
+              <a:srgbClr val="FDFCF8"/>
+            </a:solidFill>
+          </a:ln>
+          <a:effectLst/>
+        </p:spPr>
+        <p:style>
+          <a:lnRef idx="1">
+            <a:schemeClr val="accent1"/>
+          </a:lnRef>
+          <a:fillRef idx="3">
+            <a:schemeClr val="accent1"/>
+          </a:fillRef>
+          <a:effectRef idx="2">
+            <a:schemeClr val="accent1"/>
+          </a:effectRef>
+          <a:fontRef idx="minor">
+            <a:schemeClr val="lt1"/>
+          </a:fontRef>
+        </p:style>
+        <p:txBody>
+          <a:bodyPr rtlCol="0" anchor="ctr" wrap="none" lIns="0" rIns="0" tIns="0" bIns="0"/>
+          <a:lstStyle/>
+          <a:p>
+            <a:pPr algn="ctr"/>
+            <a:r>
+              <a:rPr sz="1300" b="1">
+                <a:solidFill>
+                  <a:srgbClr val="1B4BA9"/>
+                </a:solidFill>
+                <a:latin typeface="Unbounded"/>
+              </a:rPr>
+              <a:t>$</a:t>
+            </a:r>
+          </a:p>
+        </p:txBody>
+      </p:sp>
+      <p:sp>
+        <p:nvSpPr>
+          <p:cNvPr id="54" name="TextBox 53"/>
+          <p:cNvSpPr txBox="1"/>
+          <p:nvPr/>
+        </p:nvSpPr>
+        <p:spPr>
+          <a:xfrm>
+            <a:off x="7640543" y="2304288"/>
+            <a:ext cx="3728192" cy="201168"/>
+          </a:xfrm>
+          <a:prstGeom prst="rect">
+            <a:avLst/>
+          </a:prstGeom>
+          <a:noFill/>
+        </p:spPr>
+        <p:txBody>
+          <a:bodyPr wrap="square" lIns="0" rIns="0" tIns="0" bIns="0" anchor="t">
+            <a:spAutoFit/>
+          </a:bodyPr>
+          <a:lstStyle/>
+          <a:p>
+            <a:pPr algn="l">
+              <a:lnSpc>
+                <a:spcPct val="110000"/>
+              </a:lnSpc>
+              <a:spcAft>
+                <a:spcPts val="0"/>
+              </a:spcAft>
+            </a:pPr>
+            <a:r>
+              <a:rPr sz="750" b="1" i="0">
+                <a:solidFill>
+                  <a:srgbClr val="FDFCF8"/>
                 </a:solidFill>
                 <a:latin typeface="JetBrains Mono"/>
               </a:rPr>
-              <a:t>286 000 ₸</a:t>
-            </a:r>
-          </a:p>
-        </p:txBody>
-      </p:sp>
-      <p:sp>
-        <p:nvSpPr>
-          <p:cNvPr id="50" name="Rectangle 49"/>
-          <p:cNvSpPr/>
-          <p:nvPr/>
-        </p:nvSpPr>
-        <p:spPr>
-          <a:xfrm>
-            <a:off x="566928" y="4828032"/>
-            <a:ext cx="6634703" cy="420624"/>
-          </a:xfrm>
-          <a:prstGeom prst="rect">
-            <a:avLst/>
-          </a:prstGeom>
-          <a:solidFill>
-            <a:srgbClr val="1C2447"/>
-          </a:solidFill>
-          <a:ln>
-            <a:noFill/>
+              <a:t>ЗАПРАШИВАЕМАЯ СУММА</a:t>
+            </a:r>
+          </a:p>
+        </p:txBody>
+      </p:sp>
+      <p:sp>
+        <p:nvSpPr>
+          <p:cNvPr id="55" name="TextBox 54"/>
+          <p:cNvSpPr txBox="1"/>
+          <p:nvPr/>
+        </p:nvSpPr>
+        <p:spPr>
+          <a:xfrm>
+            <a:off x="7640543" y="2542032"/>
+            <a:ext cx="3728192" cy="438912"/>
+          </a:xfrm>
+          <a:prstGeom prst="rect">
+            <a:avLst/>
+          </a:prstGeom>
+          <a:noFill/>
+        </p:spPr>
+        <p:txBody>
+          <a:bodyPr wrap="square" lIns="0" rIns="0" tIns="0" bIns="0" anchor="t">
+            <a:spAutoFit/>
+          </a:bodyPr>
+          <a:lstStyle/>
+          <a:p>
+            <a:pPr algn="l">
+              <a:lnSpc>
+                <a:spcPct val="100000"/>
+              </a:lnSpc>
+              <a:spcAft>
+                <a:spcPts val="0"/>
+              </a:spcAft>
+            </a:pPr>
+            <a:r>
+              <a:rPr sz="2300" b="1" i="0">
+                <a:solidFill>
+                  <a:srgbClr val="FDFCF8"/>
+                </a:solidFill>
+                <a:latin typeface="Unbounded"/>
+              </a:rPr>
+              <a:t>$10 000</a:t>
+            </a:r>
+          </a:p>
+        </p:txBody>
+      </p:sp>
+      <p:sp>
+        <p:nvSpPr>
+          <p:cNvPr id="56" name="TextBox 55"/>
+          <p:cNvSpPr txBox="1"/>
+          <p:nvPr/>
+        </p:nvSpPr>
+        <p:spPr>
+          <a:xfrm>
+            <a:off x="7640543" y="2999232"/>
+            <a:ext cx="3728192" cy="365760"/>
+          </a:xfrm>
+          <a:prstGeom prst="rect">
+            <a:avLst/>
+          </a:prstGeom>
+          <a:noFill/>
+        </p:spPr>
+        <p:txBody>
+          <a:bodyPr wrap="square" lIns="0" rIns="0" tIns="0" bIns="0" anchor="t">
+            <a:spAutoFit/>
+          </a:bodyPr>
+          <a:lstStyle/>
+          <a:p>
+            <a:pPr algn="l">
+              <a:lnSpc>
+                <a:spcPct val="126000"/>
+              </a:lnSpc>
+              <a:spcAft>
+                <a:spcPts val="0"/>
+              </a:spcAft>
+            </a:pPr>
+            <a:r>
+              <a:rPr sz="850" b="0" i="0">
+                <a:solidFill>
+                  <a:srgbClr val="FDFCF8"/>
+                </a:solidFill>
+                <a:latin typeface="Rubik"/>
+              </a:rPr>
+              <a:t>Грант GitHub для стартапов — на AI-модели и вывод лендинга на рынок. Это около 5 300 000 ₸: смета покрывается с запасом.</a:t>
+            </a:r>
+          </a:p>
+        </p:txBody>
+      </p:sp>
+      <p:sp>
+        <p:nvSpPr>
+          <p:cNvPr id="57" name="Rounded Rectangle 56"/>
+          <p:cNvSpPr/>
+          <p:nvPr/>
+        </p:nvSpPr>
+        <p:spPr>
+          <a:xfrm>
+            <a:off x="7384511" y="3657600"/>
+            <a:ext cx="4240256" cy="1920240"/>
+          </a:xfrm>
+          <a:prstGeom prst="roundRect">
+            <a:avLst>
+              <a:gd name="adj" fmla="val 9000"/>
+            </a:avLst>
+          </a:prstGeom>
+          <a:solidFill>
+            <a:srgbClr val="E5E1D4"/>
+          </a:solidFill>
+          <a:ln w="28575">
+            <a:solidFill>
+              <a:srgbClr val="1C2447"/>
+            </a:solidFill>
           </a:ln>
           <a:effectLst/>
         </p:spPr>
@@ -19932,14 +20010,14 @@
       </p:sp>
       <p:sp>
         <p:nvSpPr>
-          <p:cNvPr id="51" name="TextBox 50"/>
+          <p:cNvPr id="58" name="TextBox 57"/>
           <p:cNvSpPr txBox="1"/>
           <p:nvPr/>
         </p:nvSpPr>
         <p:spPr>
           <a:xfrm>
-            <a:off x="713232" y="4946904"/>
-            <a:ext cx="3894059" cy="201168"/>
+            <a:off x="7640543" y="3895344"/>
+            <a:ext cx="155448" cy="731520"/>
           </a:xfrm>
           <a:prstGeom prst="rect">
             <a:avLst/>
@@ -19961,392 +20039,27 @@
               </a:spcAft>
             </a:pPr>
             <a:r>
-              <a:rPr sz="900" b="1" i="0">
-                <a:solidFill>
-                  <a:srgbClr val="FDFCF8"/>
-                </a:solidFill>
-                <a:latin typeface="Unbounded"/>
-              </a:rPr>
-              <a:t>Итого по смете</a:t>
-            </a:r>
-          </a:p>
-        </p:txBody>
-      </p:sp>
-      <p:sp>
-        <p:nvSpPr>
-          <p:cNvPr id="52" name="TextBox 51"/>
+              <a:rPr sz="950" b="1" i="0">
+                <a:solidFill>
+                  <a:srgbClr val="1B4BA9"/>
+                </a:solidFill>
+                <a:latin typeface="Rubik"/>
+              </a:rPr>
+              <a:t>✓</a:t>
+            </a:r>
+          </a:p>
+        </p:txBody>
+      </p:sp>
+      <p:sp>
+        <p:nvSpPr>
+          <p:cNvPr id="59" name="TextBox 58"/>
           <p:cNvSpPr txBox="1"/>
           <p:nvPr/>
         </p:nvSpPr>
         <p:spPr>
           <a:xfrm>
-            <a:off x="4680443" y="4946904"/>
-            <a:ext cx="2374884" cy="201168"/>
-          </a:xfrm>
-          <a:prstGeom prst="rect">
-            <a:avLst/>
-          </a:prstGeom>
-          <a:noFill/>
-        </p:spPr>
-        <p:txBody>
-          <a:bodyPr wrap="square" lIns="0" rIns="0" tIns="0" bIns="0" anchor="t">
-            <a:spAutoFit/>
-          </a:bodyPr>
-          <a:lstStyle/>
-          <a:p>
-            <a:pPr algn="r">
-              <a:lnSpc>
-                <a:spcPct val="120000"/>
-              </a:lnSpc>
-              <a:spcAft>
-                <a:spcPts val="0"/>
-              </a:spcAft>
-            </a:pPr>
-            <a:r>
-              <a:rPr sz="900" b="1" i="0">
-                <a:solidFill>
-                  <a:srgbClr val="FDFCF8"/>
-                </a:solidFill>
-                <a:latin typeface="Unbounded"/>
-              </a:rPr>
-              <a:t>4 500 000 ₸</a:t>
-            </a:r>
-          </a:p>
-        </p:txBody>
-      </p:sp>
-      <p:sp>
-        <p:nvSpPr>
-          <p:cNvPr id="53" name="Rectangle 52"/>
-          <p:cNvSpPr/>
-          <p:nvPr/>
-        </p:nvSpPr>
-        <p:spPr>
-          <a:xfrm>
-            <a:off x="566928" y="1517904"/>
-            <a:ext cx="6634703" cy="3730752"/>
-          </a:xfrm>
-          <a:prstGeom prst="rect">
-            <a:avLst/>
-          </a:prstGeom>
-          <a:noFill/>
-          <a:ln w="28575">
-            <a:solidFill>
-              <a:srgbClr val="1C2447"/>
-            </a:solidFill>
-          </a:ln>
-          <a:effectLst/>
-        </p:spPr>
-        <p:style>
-          <a:lnRef idx="1">
-            <a:schemeClr val="accent1"/>
-          </a:lnRef>
-          <a:fillRef idx="3">
-            <a:schemeClr val="accent1"/>
-          </a:fillRef>
-          <a:effectRef idx="2">
-            <a:schemeClr val="accent1"/>
-          </a:effectRef>
-          <a:fontRef idx="minor">
-            <a:schemeClr val="lt1"/>
-          </a:fontRef>
-        </p:style>
-        <p:txBody>
-          <a:bodyPr rtlCol="0" anchor="ctr"/>
-          <a:lstStyle/>
-          <a:p>
-            <a:pPr algn="ctr"/>
-          </a:p>
-        </p:txBody>
-      </p:sp>
-      <p:sp>
-        <p:nvSpPr>
-          <p:cNvPr id="54" name="Rounded Rectangle 53"/>
-          <p:cNvSpPr/>
-          <p:nvPr/>
-        </p:nvSpPr>
-        <p:spPr>
-          <a:xfrm>
-            <a:off x="7384511" y="1517904"/>
-            <a:ext cx="4240256" cy="1920240"/>
-          </a:xfrm>
-          <a:prstGeom prst="roundRect">
-            <a:avLst>
-              <a:gd name="adj" fmla="val 9000"/>
-            </a:avLst>
-          </a:prstGeom>
-          <a:solidFill>
-            <a:srgbClr val="1B4BA9"/>
-          </a:solidFill>
-          <a:ln w="28575">
-            <a:solidFill>
-              <a:srgbClr val="1C2447"/>
-            </a:solidFill>
-          </a:ln>
-          <a:effectLst/>
-        </p:spPr>
-        <p:style>
-          <a:lnRef idx="1">
-            <a:schemeClr val="accent1"/>
-          </a:lnRef>
-          <a:fillRef idx="3">
-            <a:schemeClr val="accent1"/>
-          </a:fillRef>
-          <a:effectRef idx="2">
-            <a:schemeClr val="accent1"/>
-          </a:effectRef>
-          <a:fontRef idx="minor">
-            <a:schemeClr val="lt1"/>
-          </a:fontRef>
-        </p:style>
-        <p:txBody>
-          <a:bodyPr rtlCol="0" anchor="ctr"/>
-          <a:lstStyle/>
-          <a:p>
-            <a:pPr algn="ctr"/>
-          </a:p>
-        </p:txBody>
-      </p:sp>
-      <p:sp>
-        <p:nvSpPr>
-          <p:cNvPr id="55" name="Rounded Rectangle 54"/>
-          <p:cNvSpPr/>
-          <p:nvPr/>
-        </p:nvSpPr>
-        <p:spPr>
-          <a:xfrm>
-            <a:off x="7640543" y="1755648"/>
-            <a:ext cx="384048" cy="384048"/>
-          </a:xfrm>
-          <a:prstGeom prst="roundRect">
-            <a:avLst>
-              <a:gd name="adj" fmla="val 16000"/>
-            </a:avLst>
-          </a:prstGeom>
-          <a:solidFill>
-            <a:srgbClr val="FDFCF8"/>
-          </a:solidFill>
-          <a:ln w="28575">
-            <a:solidFill>
-              <a:srgbClr val="FDFCF8"/>
-            </a:solidFill>
-          </a:ln>
-          <a:effectLst/>
-        </p:spPr>
-        <p:style>
-          <a:lnRef idx="1">
-            <a:schemeClr val="accent1"/>
-          </a:lnRef>
-          <a:fillRef idx="3">
-            <a:schemeClr val="accent1"/>
-          </a:fillRef>
-          <a:effectRef idx="2">
-            <a:schemeClr val="accent1"/>
-          </a:effectRef>
-          <a:fontRef idx="minor">
-            <a:schemeClr val="lt1"/>
-          </a:fontRef>
-        </p:style>
-        <p:txBody>
-          <a:bodyPr rtlCol="0" anchor="ctr" wrap="none" lIns="0" rIns="0" tIns="0" bIns="0"/>
-          <a:lstStyle/>
-          <a:p>
-            <a:pPr algn="ctr"/>
-            <a:r>
-              <a:rPr sz="1300" b="1">
-                <a:solidFill>
-                  <a:srgbClr val="1B4BA9"/>
-                </a:solidFill>
-                <a:latin typeface="Unbounded"/>
-              </a:rPr>
-              <a:t>₸</a:t>
-            </a:r>
-          </a:p>
-        </p:txBody>
-      </p:sp>
-      <p:sp>
-        <p:nvSpPr>
-          <p:cNvPr id="56" name="TextBox 55"/>
-          <p:cNvSpPr txBox="1"/>
-          <p:nvPr/>
-        </p:nvSpPr>
-        <p:spPr>
-          <a:xfrm>
-            <a:off x="7640543" y="2304288"/>
-            <a:ext cx="3728192" cy="201168"/>
-          </a:xfrm>
-          <a:prstGeom prst="rect">
-            <a:avLst/>
-          </a:prstGeom>
-          <a:noFill/>
-        </p:spPr>
-        <p:txBody>
-          <a:bodyPr wrap="square" lIns="0" rIns="0" tIns="0" bIns="0" anchor="t">
-            <a:spAutoFit/>
-          </a:bodyPr>
-          <a:lstStyle/>
-          <a:p>
-            <a:pPr algn="l">
-              <a:lnSpc>
-                <a:spcPct val="110000"/>
-              </a:lnSpc>
-              <a:spcAft>
-                <a:spcPts val="0"/>
-              </a:spcAft>
-            </a:pPr>
-            <a:r>
-              <a:rPr sz="750" b="1" i="0">
-                <a:solidFill>
-                  <a:srgbClr val="FDFCF8"/>
-                </a:solidFill>
-                <a:latin typeface="JetBrains Mono"/>
-              </a:rPr>
-              <a:t>ЗАПРАШИВАЕМАЯ СУММА</a:t>
-            </a:r>
-          </a:p>
-        </p:txBody>
-      </p:sp>
-      <p:sp>
-        <p:nvSpPr>
-          <p:cNvPr id="57" name="TextBox 56"/>
-          <p:cNvSpPr txBox="1"/>
-          <p:nvPr/>
-        </p:nvSpPr>
-        <p:spPr>
-          <a:xfrm>
-            <a:off x="7640543" y="2542032"/>
-            <a:ext cx="3728192" cy="438912"/>
-          </a:xfrm>
-          <a:prstGeom prst="rect">
-            <a:avLst/>
-          </a:prstGeom>
-          <a:noFill/>
-        </p:spPr>
-        <p:txBody>
-          <a:bodyPr wrap="square" lIns="0" rIns="0" tIns="0" bIns="0" anchor="t">
-            <a:spAutoFit/>
-          </a:bodyPr>
-          <a:lstStyle/>
-          <a:p>
-            <a:pPr algn="l">
-              <a:lnSpc>
-                <a:spcPct val="100000"/>
-              </a:lnSpc>
-              <a:spcAft>
-                <a:spcPts val="0"/>
-              </a:spcAft>
-            </a:pPr>
-            <a:r>
-              <a:rPr sz="2300" b="1" i="0">
-                <a:solidFill>
-                  <a:srgbClr val="FDFCF8"/>
-                </a:solidFill>
-                <a:latin typeface="Unbounded"/>
-              </a:rPr>
-              <a:t>4 500 000 ₸</a:t>
-            </a:r>
-          </a:p>
-        </p:txBody>
-      </p:sp>
-      <p:sp>
-        <p:nvSpPr>
-          <p:cNvPr id="58" name="TextBox 57"/>
-          <p:cNvSpPr txBox="1"/>
-          <p:nvPr/>
-        </p:nvSpPr>
-        <p:spPr>
-          <a:xfrm>
-            <a:off x="7640543" y="2999232"/>
-            <a:ext cx="3728192" cy="365760"/>
-          </a:xfrm>
-          <a:prstGeom prst="rect">
-            <a:avLst/>
-          </a:prstGeom>
-          <a:noFill/>
-        </p:spPr>
-        <p:txBody>
-          <a:bodyPr wrap="square" lIns="0" rIns="0" tIns="0" bIns="0" anchor="t">
-            <a:spAutoFit/>
-          </a:bodyPr>
-          <a:lstStyle/>
-          <a:p>
-            <a:pPr algn="l">
-              <a:lnSpc>
-                <a:spcPct val="126000"/>
-              </a:lnSpc>
-              <a:spcAft>
-                <a:spcPts val="0"/>
-              </a:spcAft>
-            </a:pPr>
-            <a:r>
-              <a:rPr sz="850" b="0" i="0">
-                <a:solidFill>
-                  <a:srgbClr val="FDFCF8"/>
-                </a:solidFill>
-                <a:latin typeface="Rubik"/>
-              </a:rPr>
-              <a:t>Четыре миллиона пятьсот тысяч тенге на 12 месяцев — вся смета целиком.</a:t>
-            </a:r>
-          </a:p>
-        </p:txBody>
-      </p:sp>
-      <p:sp>
-        <p:nvSpPr>
-          <p:cNvPr id="59" name="Rounded Rectangle 58"/>
-          <p:cNvSpPr/>
-          <p:nvPr/>
-        </p:nvSpPr>
-        <p:spPr>
-          <a:xfrm>
-            <a:off x="7384511" y="3657600"/>
-            <a:ext cx="4240256" cy="1920240"/>
-          </a:xfrm>
-          <a:prstGeom prst="roundRect">
-            <a:avLst>
-              <a:gd name="adj" fmla="val 9000"/>
-            </a:avLst>
-          </a:prstGeom>
-          <a:solidFill>
-            <a:srgbClr val="E5E1D4"/>
-          </a:solidFill>
-          <a:ln w="28575">
-            <a:solidFill>
-              <a:srgbClr val="1C2447"/>
-            </a:solidFill>
-          </a:ln>
-          <a:effectLst/>
-        </p:spPr>
-        <p:style>
-          <a:lnRef idx="1">
-            <a:schemeClr val="accent1"/>
-          </a:lnRef>
-          <a:fillRef idx="3">
-            <a:schemeClr val="accent1"/>
-          </a:fillRef>
-          <a:effectRef idx="2">
-            <a:schemeClr val="accent1"/>
-          </a:effectRef>
-          <a:fontRef idx="minor">
-            <a:schemeClr val="lt1"/>
-          </a:fontRef>
-        </p:style>
-        <p:txBody>
-          <a:bodyPr rtlCol="0" anchor="ctr"/>
-          <a:lstStyle/>
-          <a:p>
-            <a:pPr algn="ctr"/>
-          </a:p>
-        </p:txBody>
-      </p:sp>
-      <p:sp>
-        <p:nvSpPr>
-          <p:cNvPr id="60" name="TextBox 59"/>
-          <p:cNvSpPr txBox="1"/>
-          <p:nvPr/>
-        </p:nvSpPr>
-        <p:spPr>
-          <a:xfrm>
-            <a:off x="7640543" y="3895344"/>
-            <a:ext cx="155448" cy="731520"/>
+            <a:off x="7823423" y="3895344"/>
+            <a:ext cx="3545312" cy="731520"/>
           </a:xfrm>
           <a:prstGeom prst="rect">
             <a:avLst/>
@@ -20368,27 +20081,36 @@
               </a:spcAft>
             </a:pPr>
             <a:r>
-              <a:rPr sz="950" b="1" i="0">
-                <a:solidFill>
-                  <a:srgbClr val="1B4BA9"/>
+              <a:rPr sz="800" b="1" i="0">
+                <a:solidFill>
+                  <a:srgbClr val="1C2447"/>
                 </a:solidFill>
                 <a:latin typeface="Rubik"/>
               </a:rPr>
-              <a:t>✓</a:t>
-            </a:r>
-          </a:p>
-        </p:txBody>
-      </p:sp>
-      <p:sp>
-        <p:nvSpPr>
-          <p:cNvPr id="61" name="TextBox 60"/>
+              <a:t>Инвестиции сейчас не привлекаем. </a:t>
+            </a:r>
+            <a:r>
+              <a:rPr sz="800" b="0" i="0">
+                <a:solidFill>
+                  <a:srgbClr val="5A6180"/>
+                </a:solidFill>
+                <a:latin typeface="Rubik"/>
+              </a:rPr>
+              <a:t>Призовой фонд PIZZA PITCH — 150 000 ₸; приз закрывает домен и продвижение.</a:t>
+            </a:r>
+          </a:p>
+        </p:txBody>
+      </p:sp>
+      <p:sp>
+        <p:nvSpPr>
+          <p:cNvPr id="60" name="TextBox 59"/>
           <p:cNvSpPr txBox="1"/>
           <p:nvPr/>
         </p:nvSpPr>
         <p:spPr>
           <a:xfrm>
-            <a:off x="7823423" y="3895344"/>
-            <a:ext cx="3545312" cy="731520"/>
+            <a:off x="7640543" y="4462272"/>
+            <a:ext cx="155448" cy="731520"/>
           </a:xfrm>
           <a:prstGeom prst="rect">
             <a:avLst/>
@@ -20410,36 +20132,27 @@
               </a:spcAft>
             </a:pPr>
             <a:r>
-              <a:rPr sz="800" b="1" i="0">
-                <a:solidFill>
-                  <a:srgbClr val="1C2447"/>
+              <a:rPr sz="950" b="1" i="0">
+                <a:solidFill>
+                  <a:srgbClr val="1B4BA9"/>
                 </a:solidFill>
                 <a:latin typeface="Rubik"/>
               </a:rPr>
-              <a:t>Собственный вклад. </a:t>
-            </a:r>
-            <a:r>
-              <a:rPr sz="800" b="0" i="0">
-                <a:solidFill>
-                  <a:srgbClr val="5A6180"/>
-                </a:solidFill>
-                <a:latin typeface="Rubik"/>
-              </a:rPr>
-              <a:t>Выпущенный продукт, инфраструктура и время основателя — эквивалент 2 000 000 ₸.</a:t>
-            </a:r>
-          </a:p>
-        </p:txBody>
-      </p:sp>
-      <p:sp>
-        <p:nvSpPr>
-          <p:cNvPr id="62" name="TextBox 61"/>
+              <a:t>✓</a:t>
+            </a:r>
+          </a:p>
+        </p:txBody>
+      </p:sp>
+      <p:sp>
+        <p:nvSpPr>
+          <p:cNvPr id="61" name="TextBox 60"/>
           <p:cNvSpPr txBox="1"/>
           <p:nvPr/>
         </p:nvSpPr>
         <p:spPr>
           <a:xfrm>
-            <a:off x="7640543" y="4462272"/>
-            <a:ext cx="155448" cy="731520"/>
+            <a:off x="7823423" y="4462272"/>
+            <a:ext cx="3545312" cy="731520"/>
           </a:xfrm>
           <a:prstGeom prst="rect">
             <a:avLst/>
@@ -20461,27 +20174,36 @@
               </a:spcAft>
             </a:pPr>
             <a:r>
-              <a:rPr sz="950" b="1" i="0">
-                <a:solidFill>
-                  <a:srgbClr val="1B4BA9"/>
+              <a:rPr sz="800" b="1" i="0">
+                <a:solidFill>
+                  <a:srgbClr val="1C2447"/>
                 </a:solidFill>
                 <a:latin typeface="Rubik"/>
               </a:rPr>
-              <a:t>✓</a:t>
-            </a:r>
-          </a:p>
-        </p:txBody>
-      </p:sp>
-      <p:sp>
-        <p:nvSpPr>
-          <p:cNvPr id="63" name="TextBox 62"/>
+              <a:t>Уже вложено. </a:t>
+            </a:r>
+            <a:r>
+              <a:rPr sz="800" b="0" i="0">
+                <a:solidFill>
+                  <a:srgbClr val="5A6180"/>
+                </a:solidFill>
+                <a:latin typeface="Rubik"/>
+              </a:rPr>
+              <a:t>Продукт 2.0, открытый код и подписка на топовые AI-модели на 6 месяцев — $1 000.</a:t>
+            </a:r>
+          </a:p>
+        </p:txBody>
+      </p:sp>
+      <p:sp>
+        <p:nvSpPr>
+          <p:cNvPr id="62" name="TextBox 61"/>
           <p:cNvSpPr txBox="1"/>
           <p:nvPr/>
         </p:nvSpPr>
         <p:spPr>
           <a:xfrm>
-            <a:off x="7823423" y="4462272"/>
-            <a:ext cx="3545312" cy="731520"/>
+            <a:off x="7640543" y="5029200"/>
+            <a:ext cx="155448" cy="731520"/>
           </a:xfrm>
           <a:prstGeom prst="rect">
             <a:avLst/>
@@ -20503,36 +20225,27 @@
               </a:spcAft>
             </a:pPr>
             <a:r>
-              <a:rPr sz="800" b="1" i="0">
-                <a:solidFill>
-                  <a:srgbClr val="1C2447"/>
+              <a:rPr sz="950" b="1" i="0">
+                <a:solidFill>
+                  <a:srgbClr val="1B4BA9"/>
                 </a:solidFill>
                 <a:latin typeface="Rubik"/>
               </a:rPr>
-              <a:t>Только вывод на рынок. </a:t>
-            </a:r>
-            <a:r>
-              <a:rPr sz="800" b="0" i="0">
-                <a:solidFill>
-                  <a:srgbClr val="5A6180"/>
-                </a:solidFill>
-                <a:latin typeface="Rubik"/>
-              </a:rPr>
-              <a:t>Разработка ядра в смете отсутствует: средства идут на масштабирование.</a:t>
-            </a:r>
-          </a:p>
-        </p:txBody>
-      </p:sp>
-      <p:sp>
-        <p:nvSpPr>
-          <p:cNvPr id="64" name="TextBox 63"/>
+              <a:t>✓</a:t>
+            </a:r>
+          </a:p>
+        </p:txBody>
+      </p:sp>
+      <p:sp>
+        <p:nvSpPr>
+          <p:cNvPr id="63" name="TextBox 62"/>
           <p:cNvSpPr txBox="1"/>
           <p:nvPr/>
         </p:nvSpPr>
         <p:spPr>
           <a:xfrm>
-            <a:off x="7640543" y="5029200"/>
-            <a:ext cx="155448" cy="731520"/>
+            <a:off x="7823423" y="5029200"/>
+            <a:ext cx="3545312" cy="731520"/>
           </a:xfrm>
           <a:prstGeom prst="rect">
             <a:avLst/>
@@ -20554,64 +20267,22 @@
               </a:spcAft>
             </a:pPr>
             <a:r>
-              <a:rPr sz="950" b="1" i="0">
-                <a:solidFill>
-                  <a:srgbClr val="1B4BA9"/>
+              <a:rPr sz="800" b="1" i="0">
+                <a:solidFill>
+                  <a:srgbClr val="1C2447"/>
                 </a:solidFill>
                 <a:latin typeface="Rubik"/>
               </a:rPr>
-              <a:t>✓</a:t>
-            </a:r>
-          </a:p>
-        </p:txBody>
-      </p:sp>
-      <p:sp>
-        <p:nvSpPr>
-          <p:cNvPr id="65" name="TextBox 64"/>
-          <p:cNvSpPr txBox="1"/>
-          <p:nvPr/>
-        </p:nvSpPr>
-        <p:spPr>
-          <a:xfrm>
-            <a:off x="7823423" y="5029200"/>
-            <a:ext cx="3545312" cy="731520"/>
-          </a:xfrm>
-          <a:prstGeom prst="rect">
-            <a:avLst/>
-          </a:prstGeom>
-          <a:noFill/>
-        </p:spPr>
-        <p:txBody>
-          <a:bodyPr wrap="square" lIns="0" rIns="0" tIns="0" bIns="0" anchor="t">
-            <a:spAutoFit/>
-          </a:bodyPr>
-          <a:lstStyle/>
-          <a:p>
-            <a:pPr algn="l">
-              <a:lnSpc>
-                <a:spcPct val="120000"/>
-              </a:lnSpc>
-              <a:spcAft>
-                <a:spcPts val="0"/>
-              </a:spcAft>
-            </a:pPr>
-            <a:r>
-              <a:rPr sz="800" b="1" i="0">
-                <a:solidFill>
-                  <a:srgbClr val="1C2447"/>
+              <a:t>Возвратность. </a:t>
+            </a:r>
+            <a:r>
+              <a:rPr sz="800" b="0" i="0">
+                <a:solidFill>
+                  <a:srgbClr val="5A6180"/>
                 </a:solidFill>
                 <a:latin typeface="Rubik"/>
               </a:rPr>
-              <a:t>Возвратность. </a:t>
-            </a:r>
-            <a:r>
-              <a:rPr sz="800" b="0" i="0">
-                <a:solidFill>
-                  <a:srgbClr val="5A6180"/>
-                </a:solidFill>
-                <a:latin typeface="Rubik"/>
-              </a:rPr>
-              <a:t>Выход на выручку — Q3 2026, самоокупаемость к концу года.</a:t>
+              <a:t>WhisperFly Pro — с Q2 2027; себестоимость распознавания — центы на пользователя.</a:t>
             </a:r>
           </a:p>
         </p:txBody>
@@ -22466,7 +22137,7 @@
                 </a:solidFill>
                 <a:latin typeface="Rubik"/>
               </a:rPr>
-              <a:t>— продуктовый маркетинг и продажи: найм запланирован на Q2 2026 года.</a:t>
+              <a:t>— продуктовый маркетинг и продажи: найм запланирован на Q2 2027 года.</a:t>
             </a:r>
           </a:p>
         </p:txBody>
@@ -23883,7 +23554,7 @@
                 </a:solidFill>
                 <a:latin typeface="Rubik"/>
               </a:rPr>
-              <a:t>1,5 млн человеко-часов в год, бесплатный доступ для образования и малого бизнеса, рабочие места в 2026 году.</a:t>
+              <a:t>0,7 млн человеко-часов в год, бесплатный доступ для образования и малого бизнеса, рабочие места в 2027 году.</a:t>
             </a:r>
           </a:p>
         </p:txBody>

</xml_diff>